<commit_message>
Expand case study report with docomo cases and competitor comparison
Adds NTT docomo Business / docomo Business Solutions cases (Tamana,
Kotohira, Kyushu tourism, Miyagin, Awaji), people-flow / survey / ad
comparisons against KDDI, Agoop, Zenrin, LINE Yahoo and others,
docomo strengths, competitive reading and objection handling.
Sample proposal now cites the Kotohira and Tamana cases.

Co-Authored-By: Claude Opus 5.5 <noreply@anthropic.com>
Claude-Session: https://claude.ai/code/session_0122wdri1Yhz7WwnvnusACaQ
</commit_message>
<xml_diff>
--- a/docs/sales/提案書サンプル_〇〇市様_観光イベント.pptx
+++ b/docs/sales/提案書サンプル_〇〇市様_観光イベント.pptx
@@ -1639,10 +1639,10 @@
           <a:p>
             <a:r>
               <a:rPr lang="en-US" dirty="0"/>
-              <a:t>事例は「同じサービスでここまでできた」という参考として紹介する。当社の実績として話さない。川崎フロンターレは位置情報と決済情報を組み合わせた実証で、標準メニューとは異なる。
+              <a:t>琴平町は本提案と同じく「人の動き＋理由」を組み合わせた実例。事例は「同じサービスでここまでできた」という参考として紹介する。当社の実績として話さない。川崎フロンターレは位置情報と決済情報を組み合わせた実証で、標準メニューとは異なる。
 出典
-https://www.ntt.com/business/services/spatial_statistics/case_shigaken.html
-https://www.ntt.com/business/case-studies/mima.html
+https://www.ntt.com/business/case-studies/kotohira_town.html
+https://www.ntt.com/business/case-studies/tamana.html
 https://www.docomobs.com/case/toyama/
 https://www.intage.co.jp/news/6237/</a:t>
             </a:r>
@@ -3742,7 +3742,7 @@
                 <a:ea typeface="Meiryo" pitchFamily="34" charset="-122"/>
                 <a:cs typeface="Meiryo" pitchFamily="34" charset="-120"/>
               </a:rPr>
-              <a:t>滋賀県</a:t>
+              <a:t>香川県琴平町</a:t>
             </a:r>
             <a:endParaRPr lang="en-US" sz="1600" dirty="0"/>
           </a:p>
@@ -3781,7 +3781,7 @@
                 <a:ea typeface="Meiryo" pitchFamily="34" charset="-122"/>
                 <a:cs typeface="Meiryo" pitchFamily="34" charset="-120"/>
               </a:rPr>
-              <a:t>モバイル空間統計</a:t>
+              <a:t>モバイル空間統計＋プレミアパネル</a:t>
             </a:r>
             <a:endParaRPr lang="en-US" sz="1100" dirty="0"/>
           </a:p>
@@ -3834,7 +3834,7 @@
                 <a:ea typeface="Meiryo" pitchFamily="34" charset="-122"/>
                 <a:cs typeface="Meiryo" pitchFamily="34" charset="-120"/>
               </a:rPr>
-              <a:t>施策や呼びかけの根拠資料がなかった</a:t>
+              <a:t>手書きアンケートは50件程度で、推測に頼っていた</a:t>
             </a:r>
             <a:endParaRPr lang="en-US" sz="1250" dirty="0"/>
           </a:p>
@@ -3887,7 +3887,7 @@
                 <a:ea typeface="Meiryo" pitchFamily="34" charset="-122"/>
                 <a:cs typeface="Meiryo" pitchFamily="34" charset="-120"/>
               </a:rPr>
-              <a:t>県内56拠点の混雑をヒートマップで公開</a:t>
+              <a:t>来訪者の属性とニーズをデータでつかみ、観光戦略を立案</a:t>
             </a:r>
             <a:endParaRPr lang="en-US" sz="1250" dirty="0"/>
           </a:p>
@@ -4002,7 +4002,7 @@
                 <a:ea typeface="Meiryo" pitchFamily="34" charset="-122"/>
                 <a:cs typeface="Meiryo" pitchFamily="34" charset="-120"/>
               </a:rPr>
-              <a:t>徳島県美馬市</a:t>
+              <a:t>熊本県玉名市</a:t>
             </a:r>
             <a:endParaRPr lang="en-US" sz="1600" dirty="0"/>
           </a:p>
@@ -4094,7 +4094,7 @@
                 <a:ea typeface="Meiryo" pitchFamily="34" charset="-122"/>
                 <a:cs typeface="Meiryo" pitchFamily="34" charset="-120"/>
               </a:rPr>
-              <a:t>観光客数が伸び悩む通過型の観光地</a:t>
+              <a:t>RESASでは県単位までしか見えず、国別の人数が不明</a:t>
             </a:r>
             <a:endParaRPr lang="en-US" sz="1250" dirty="0"/>
           </a:p>
@@ -4147,7 +4147,7 @@
                 <a:ea typeface="Meiryo" pitchFamily="34" charset="-122"/>
                 <a:cs typeface="Meiryo" pitchFamily="34" charset="-120"/>
               </a:rPr>
-              <a:t>観光客の属性別データを観光施策の立案に活用</a:t>
+              <a:t>重点国を決めて誘致し、温泉施設に泊まる外国人客が増加</a:t>
             </a:r>
             <a:endParaRPr lang="en-US" sz="1250" dirty="0"/>
           </a:p>
@@ -8775,7 +8775,7 @@
                 <a:ea typeface="Meiryo" pitchFamily="34" charset="-122"/>
                 <a:cs typeface="Meiryo" pitchFamily="34" charset="-120"/>
               </a:rPr>
-              <a:t>https://www.ntt.com/business/services/spatial_statistics/case_shigaken.html</a:t>
+              <a:t>https://www.ntt.com/business/case-studies/kotohira_town.html</a:t>
             </a:r>
             <a:endParaRPr lang="en-US" sz="1050" dirty="0"/>
           </a:p>
@@ -8792,7 +8792,7 @@
                 <a:ea typeface="Meiryo" pitchFamily="34" charset="-122"/>
                 <a:cs typeface="Meiryo" pitchFamily="34" charset="-120"/>
               </a:rPr>
-              <a:t>https://www.ntt.com/business/case-studies/mima.html</a:t>
+              <a:t>https://www.ntt.com/business/case-studies/tamana.html</a:t>
             </a:r>
             <a:endParaRPr lang="en-US" sz="1050" dirty="0"/>
           </a:p>

</xml_diff>